<commit_message>
Update 릴레이 공 옮기기 assets and add ZIP slides
Co-Authored-By: Claude Opus 4.6 (1M context) <noreply@anthropic.com>
</commit_message>
<xml_diff>
--- a/public/downloads/games/relay-ball-pipe/rules.pptx
+++ b/public/downloads/games/relay-ball-pipe/rules.pptx
@@ -15,16 +15,12 @@
   <p:notesSz cx="6858000" cy="9144000"/>
   <p:embeddedFontLst>
     <p:embeddedFont>
-      <p:font typeface="Jua" charset="1" panose="00000000000000000000"/>
+      <p:font typeface="무궁화 고딕" charset="1" panose="02020603020101020101"/>
       <p:regular r:id="rId11"/>
     </p:embeddedFont>
     <p:embeddedFont>
-      <p:font typeface="TDTD갬성명조" charset="1" panose="02000503000000000000"/>
+      <p:font typeface="무궁화 고딕 Bold" charset="1" panose="02020603020101020101"/>
       <p:regular r:id="rId12"/>
-    </p:embeddedFont>
-    <p:embeddedFont>
-      <p:font typeface="TDTD가온" charset="1" panose="02000503000000000000"/>
-      <p:regular r:id="rId13"/>
     </p:embeddedFont>
   </p:embeddedFontLst>
   <p:defaultTextStyle>
@@ -3142,8 +3138,8 @@
         </p:nvSpPr>
         <p:spPr>
           <a:xfrm rot="0">
-            <a:off x="1028700" y="3892867"/>
-            <a:ext cx="15555091" cy="2200275"/>
+            <a:off x="1028700" y="4178617"/>
+            <a:ext cx="15555091" cy="1914525"/>
           </a:xfrm>
           <a:prstGeom prst="rect">
             <a:avLst/>
@@ -3165,10 +3161,10 @@
                 <a:solidFill>
                   <a:srgbClr val="FFFAEF"/>
                 </a:solidFill>
-                <a:latin typeface="Jua"/>
-                <a:ea typeface="Jua"/>
-                <a:cs typeface="Jua"/>
-                <a:sym typeface="Jua"/>
+                <a:latin typeface="무궁화 고딕"/>
+                <a:ea typeface="무궁화 고딕"/>
+                <a:cs typeface="무궁화 고딕"/>
+                <a:sym typeface="무궁화 고딕"/>
               </a:rPr>
               <a:t>릴레이 공 옮기기</a:t>
             </a:r>
@@ -3183,8 +3179,8 @@
         </p:nvSpPr>
         <p:spPr>
           <a:xfrm rot="0">
-            <a:off x="15264803" y="9812655"/>
-            <a:ext cx="2637975" cy="474345"/>
+            <a:off x="14863751" y="9822180"/>
+            <a:ext cx="3039028" cy="464820"/>
           </a:xfrm>
           <a:prstGeom prst="rect">
             <a:avLst/>
@@ -3209,10 +3205,10 @@
                 <a:solidFill>
                   <a:srgbClr val="FFFFFF"/>
                 </a:solidFill>
-                <a:latin typeface="TDTD갬성명조"/>
-                <a:ea typeface="TDTD갬성명조"/>
-                <a:cs typeface="TDTD갬성명조"/>
-                <a:sym typeface="TDTD갬성명조"/>
+                <a:latin typeface="무궁화 고딕"/>
+                <a:ea typeface="무궁화 고딕"/>
+                <a:cs typeface="무궁화 고딕"/>
+                <a:sym typeface="무궁화 고딕"/>
               </a:rPr>
               <a:t>ⓒ 2026. Sunday Play</a:t>
             </a:r>
@@ -3361,8 +3357,8 @@
         </p:nvSpPr>
         <p:spPr>
           <a:xfrm rot="0">
-            <a:off x="11392761" y="600705"/>
-            <a:ext cx="5362043" cy="1600200"/>
+            <a:off x="11392761" y="819780"/>
+            <a:ext cx="5362043" cy="1381125"/>
           </a:xfrm>
           <a:prstGeom prst="rect">
             <a:avLst/>
@@ -3384,10 +3380,10 @@
                 <a:solidFill>
                   <a:srgbClr val="FFFAEF"/>
                 </a:solidFill>
-                <a:latin typeface="Jua"/>
-                <a:ea typeface="Jua"/>
-                <a:cs typeface="Jua"/>
-                <a:sym typeface="Jua"/>
+                <a:latin typeface="무궁화 고딕"/>
+                <a:ea typeface="무궁화 고딕"/>
+                <a:cs typeface="무궁화 고딕"/>
+                <a:sym typeface="무궁화 고딕"/>
               </a:rPr>
               <a:t>규칙</a:t>
             </a:r>
@@ -3403,9 +3399,9 @@
         <p:grpSpPr>
           <a:xfrm rot="0">
             <a:off x="309172" y="535073"/>
-            <a:ext cx="10694683" cy="2573620"/>
+            <a:ext cx="10694683" cy="2442580"/>
             <a:chOff x="0" y="0"/>
-            <a:chExt cx="14259577" cy="3431493"/>
+            <a:chExt cx="14259577" cy="3256774"/>
           </a:xfrm>
         </p:grpSpPr>
         <p:sp>
@@ -3416,8 +3412,8 @@
           </p:nvSpPr>
           <p:spPr>
             <a:xfrm rot="0">
-              <a:off x="0" y="1380584"/>
-              <a:ext cx="14259577" cy="2050910"/>
+              <a:off x="0" y="1378853"/>
+              <a:ext cx="14259577" cy="1877921"/>
             </a:xfrm>
             <a:prstGeom prst="rect">
               <a:avLst/>
@@ -3431,18 +3427,18 @@
             <a:p>
               <a:pPr algn="l">
                 <a:lnSpc>
-                  <a:spcPts val="6273"/>
+                  <a:spcPts val="5713"/>
                 </a:lnSpc>
               </a:pPr>
               <a:r>
-                <a:rPr lang="en-US" sz="4480">
+                <a:rPr lang="en-US" sz="4080">
                   <a:solidFill>
                     <a:srgbClr val="FFFAEF"/>
                   </a:solidFill>
-                  <a:latin typeface="TDTD가온"/>
-                  <a:ea typeface="TDTD가온"/>
-                  <a:cs typeface="TDTD가온"/>
-                  <a:sym typeface="TDTD가온"/>
+                  <a:latin typeface="무궁화 고딕"/>
+                  <a:ea typeface="무궁화 고딕"/>
+                  <a:cs typeface="무궁화 고딕"/>
+                  <a:sym typeface="무궁화 고딕"/>
                 </a:rPr>
                 <a:t>U보드를 들고 일렬로 서서</a:t>
               </a:r>
@@ -3450,30 +3446,30 @@
             <a:p>
               <a:pPr algn="l">
                 <a:lnSpc>
-                  <a:spcPts val="6273"/>
+                  <a:spcPts val="5713"/>
                 </a:lnSpc>
               </a:pPr>
               <a:r>
-                <a:rPr lang="en-US" sz="4480">
+                <a:rPr lang="en-US" sz="4080">
                   <a:solidFill>
                     <a:srgbClr val="FFFAEF"/>
                   </a:solidFill>
-                  <a:latin typeface="TDTD가온"/>
-                  <a:ea typeface="TDTD가온"/>
-                  <a:cs typeface="TDTD가온"/>
-                  <a:sym typeface="TDTD가온"/>
+                  <a:latin typeface="무궁화 고딕"/>
+                  <a:ea typeface="무궁화 고딕"/>
+                  <a:cs typeface="무궁화 고딕"/>
+                  <a:sym typeface="무궁화 고딕"/>
                 </a:rPr>
                 <a:t>첫 주</a:t>
               </a:r>
               <a:r>
-                <a:rPr lang="en-US" sz="4480">
+                <a:rPr lang="en-US" sz="4080">
                   <a:solidFill>
                     <a:srgbClr val="FFFAEF"/>
                   </a:solidFill>
-                  <a:latin typeface="TDTD가온"/>
-                  <a:ea typeface="TDTD가온"/>
-                  <a:cs typeface="TDTD가온"/>
-                  <a:sym typeface="TDTD가온"/>
+                  <a:latin typeface="무궁화 고딕"/>
+                  <a:ea typeface="무궁화 고딕"/>
+                  <a:cs typeface="무궁화 고딕"/>
+                  <a:sym typeface="무궁화 고딕"/>
                 </a:rPr>
                 <a:t>자가 공을 굴립니다.</a:t>
               </a:r>
@@ -3488,8 +3484,8 @@
           </p:nvSpPr>
           <p:spPr>
             <a:xfrm rot="0">
-              <a:off x="0" y="-171450"/>
-              <a:ext cx="9574913" cy="1169217"/>
+              <a:off x="0" y="-66675"/>
+              <a:ext cx="9574913" cy="1062712"/>
             </a:xfrm>
             <a:prstGeom prst="rect">
               <a:avLst/>
@@ -3511,10 +3507,10 @@
                   <a:solidFill>
                     <a:srgbClr val="FFFAEF"/>
                   </a:solidFill>
-                  <a:latin typeface="Jua"/>
-                  <a:ea typeface="Jua"/>
-                  <a:cs typeface="Jua"/>
-                  <a:sym typeface="Jua"/>
+                  <a:latin typeface="무궁화 고딕 Bold"/>
+                  <a:ea typeface="무궁화 고딕 Bold"/>
+                  <a:cs typeface="무궁화 고딕 Bold"/>
+                  <a:sym typeface="무궁화 고딕 Bold"/>
                 </a:rPr>
                 <a:t>STEP 1.</a:t>
               </a:r>
@@ -3531,9 +3527,9 @@
         <p:grpSpPr>
           <a:xfrm rot="0">
             <a:off x="11164326" y="8200435"/>
-            <a:ext cx="6341492" cy="1778769"/>
+            <a:ext cx="6341492" cy="1714645"/>
             <a:chOff x="0" y="0"/>
-            <a:chExt cx="8455322" cy="2371692"/>
+            <a:chExt cx="8455322" cy="2286193"/>
           </a:xfrm>
         </p:grpSpPr>
         <p:sp>
@@ -3544,8 +3540,8 @@
           </p:nvSpPr>
           <p:spPr>
             <a:xfrm rot="0">
-              <a:off x="0" y="1377534"/>
-              <a:ext cx="8326056" cy="994158"/>
+              <a:off x="0" y="1373758"/>
+              <a:ext cx="8326056" cy="912435"/>
             </a:xfrm>
             <a:prstGeom prst="rect">
               <a:avLst/>
@@ -3559,18 +3555,18 @@
             <a:p>
               <a:pPr algn="l">
                 <a:lnSpc>
-                  <a:spcPts val="6284"/>
+                  <a:spcPts val="5724"/>
                 </a:lnSpc>
               </a:pPr>
               <a:r>
-                <a:rPr lang="en-US" sz="4489">
+                <a:rPr lang="en-US" sz="4089">
                   <a:solidFill>
                     <a:srgbClr val="FFFAEF"/>
                   </a:solidFill>
-                  <a:latin typeface="TDTD가온"/>
-                  <a:ea typeface="TDTD가온"/>
-                  <a:cs typeface="TDTD가온"/>
-                  <a:sym typeface="TDTD가온"/>
+                  <a:latin typeface="무궁화 고딕"/>
+                  <a:ea typeface="무궁화 고딕"/>
+                  <a:cs typeface="무궁화 고딕"/>
+                  <a:sym typeface="무궁화 고딕"/>
                 </a:rPr>
                 <a:t>컵에 먼저 골인하는 팀이 승리!</a:t>
               </a:r>
@@ -3585,8 +3581,8 @@
           </p:nvSpPr>
           <p:spPr>
             <a:xfrm rot="0">
-              <a:off x="0" y="-171450"/>
-              <a:ext cx="8455322" cy="1171105"/>
+              <a:off x="0" y="-57150"/>
+              <a:ext cx="8455322" cy="1053029"/>
             </a:xfrm>
             <a:prstGeom prst="rect">
               <a:avLst/>
@@ -3608,10 +3604,10 @@
                   <a:solidFill>
                     <a:srgbClr val="FFFAEF"/>
                   </a:solidFill>
-                  <a:latin typeface="Jua"/>
-                  <a:ea typeface="Jua"/>
-                  <a:cs typeface="Jua"/>
-                  <a:sym typeface="Jua"/>
+                  <a:latin typeface="무궁화 고딕 Bold"/>
+                  <a:ea typeface="무궁화 고딕 Bold"/>
+                  <a:cs typeface="무궁화 고딕 Bold"/>
+                  <a:sym typeface="무궁화 고딕 Bold"/>
                 </a:rPr>
                 <a:t>STEP 3.</a:t>
               </a:r>
@@ -3628,9 +3624,9 @@
         <p:grpSpPr>
           <a:xfrm rot="0">
             <a:off x="5656513" y="3679522"/>
-            <a:ext cx="8678559" cy="3364141"/>
+            <a:ext cx="8678559" cy="3162174"/>
             <a:chOff x="0" y="0"/>
-            <a:chExt cx="11571412" cy="4485521"/>
+            <a:chExt cx="11571412" cy="4216232"/>
           </a:xfrm>
         </p:grpSpPr>
         <p:sp>
@@ -3641,8 +3637,8 @@
           </p:nvSpPr>
           <p:spPr>
             <a:xfrm rot="0">
-              <a:off x="0" y="1375218"/>
-              <a:ext cx="11571412" cy="3110303"/>
+              <a:off x="0" y="1373156"/>
+              <a:ext cx="11571412" cy="2843075"/>
             </a:xfrm>
             <a:prstGeom prst="rect">
               <a:avLst/>
@@ -3656,18 +3652,18 @@
             <a:p>
               <a:pPr algn="l">
                 <a:lnSpc>
-                  <a:spcPts val="6275"/>
+                  <a:spcPts val="5715"/>
                 </a:lnSpc>
               </a:pPr>
               <a:r>
-                <a:rPr lang="en-US" sz="4482">
+                <a:rPr lang="en-US" sz="4082">
                   <a:solidFill>
                     <a:srgbClr val="FFFAEF"/>
                   </a:solidFill>
-                  <a:latin typeface="TDTD가온"/>
-                  <a:ea typeface="TDTD가온"/>
-                  <a:cs typeface="TDTD가온"/>
-                  <a:sym typeface="TDTD가온"/>
+                  <a:latin typeface="무궁화 고딕"/>
+                  <a:ea typeface="무궁화 고딕"/>
+                  <a:cs typeface="무궁화 고딕"/>
+                  <a:sym typeface="무궁화 고딕"/>
                 </a:rPr>
                 <a:t>공이 지나가면 맨 뒤로 달려가</a:t>
               </a:r>
@@ -3675,18 +3671,18 @@
             <a:p>
               <a:pPr algn="l">
                 <a:lnSpc>
-                  <a:spcPts val="6275"/>
+                  <a:spcPts val="5715"/>
                 </a:lnSpc>
               </a:pPr>
               <a:r>
-                <a:rPr lang="en-US" sz="4482">
+                <a:rPr lang="en-US" sz="4082">
                   <a:solidFill>
                     <a:srgbClr val="FFFAEF"/>
                   </a:solidFill>
-                  <a:latin typeface="TDTD가온"/>
-                  <a:ea typeface="TDTD가온"/>
-                  <a:cs typeface="TDTD가온"/>
-                  <a:sym typeface="TDTD가온"/>
+                  <a:latin typeface="무궁화 고딕"/>
+                  <a:ea typeface="무궁화 고딕"/>
+                  <a:cs typeface="무궁화 고딕"/>
+                  <a:sym typeface="무궁화 고딕"/>
                 </a:rPr>
                 <a:t>계속 굴러가도록 연결!</a:t>
               </a:r>
@@ -3694,18 +3690,18 @@
             <a:p>
               <a:pPr algn="l">
                 <a:lnSpc>
-                  <a:spcPts val="6275"/>
+                  <a:spcPts val="5715"/>
                 </a:lnSpc>
               </a:pPr>
               <a:r>
-                <a:rPr lang="en-US" sz="4482">
+                <a:rPr lang="en-US" sz="4082">
                   <a:solidFill>
                     <a:srgbClr val="FFFAEF"/>
                   </a:solidFill>
-                  <a:latin typeface="TDTD가온"/>
-                  <a:ea typeface="TDTD가온"/>
-                  <a:cs typeface="TDTD가온"/>
-                  <a:sym typeface="TDTD가온"/>
+                  <a:latin typeface="무궁화 고딕"/>
+                  <a:ea typeface="무궁화 고딕"/>
+                  <a:cs typeface="무궁화 고딕"/>
+                  <a:sym typeface="무궁화 고딕"/>
                 </a:rPr>
                 <a:t>(공을 떨어뜨리면 처음부터 다시)</a:t>
               </a:r>
@@ -3720,8 +3716,8 @@
           </p:nvSpPr>
           <p:spPr>
             <a:xfrm rot="0">
-              <a:off x="0" y="-171450"/>
-              <a:ext cx="7133890" cy="1169523"/>
+              <a:off x="0" y="-57150"/>
+              <a:ext cx="7133890" cy="1053161"/>
             </a:xfrm>
             <a:prstGeom prst="rect">
               <a:avLst/>
@@ -3743,10 +3739,10 @@
                   <a:solidFill>
                     <a:srgbClr val="FFFAEF"/>
                   </a:solidFill>
-                  <a:latin typeface="Jua"/>
-                  <a:ea typeface="Jua"/>
-                  <a:cs typeface="Jua"/>
-                  <a:sym typeface="Jua"/>
+                  <a:latin typeface="무궁화 고딕 Bold"/>
+                  <a:ea typeface="무궁화 고딕 Bold"/>
+                  <a:cs typeface="무궁화 고딕 Bold"/>
+                  <a:sym typeface="무궁화 고딕 Bold"/>
                 </a:rPr>
                 <a:t>STEP 2.</a:t>
               </a:r>
@@ -3794,8 +3790,8 @@
         </p:nvSpPr>
         <p:spPr>
           <a:xfrm rot="0">
-            <a:off x="3238925" y="4092795"/>
-            <a:ext cx="11810151" cy="2200275"/>
+            <a:off x="3238925" y="4378545"/>
+            <a:ext cx="11810151" cy="1914525"/>
           </a:xfrm>
           <a:prstGeom prst="rect">
             <a:avLst/>
@@ -3817,10 +3813,10 @@
                 <a:solidFill>
                   <a:srgbClr val="000000"/>
                 </a:solidFill>
-                <a:latin typeface="Jua"/>
-                <a:ea typeface="Jua"/>
-                <a:cs typeface="Jua"/>
-                <a:sym typeface="Jua"/>
+                <a:latin typeface="무궁화 고딕"/>
+                <a:ea typeface="무궁화 고딕"/>
+                <a:cs typeface="무궁화 고딕"/>
+                <a:sym typeface="무궁화 고딕"/>
               </a:rPr>
               <a:t>팀을 나눠주세요!</a:t>
             </a:r>
@@ -3967,8 +3963,8 @@
         </p:nvSpPr>
         <p:spPr>
           <a:xfrm rot="0">
-            <a:off x="1028700" y="3892867"/>
-            <a:ext cx="15555091" cy="2200275"/>
+            <a:off x="1028700" y="4178617"/>
+            <a:ext cx="15555091" cy="1914525"/>
           </a:xfrm>
           <a:prstGeom prst="rect">
             <a:avLst/>
@@ -3990,10 +3986,10 @@
                 <a:solidFill>
                   <a:srgbClr val="FFFAEF"/>
                 </a:solidFill>
-                <a:latin typeface="Jua"/>
-                <a:ea typeface="Jua"/>
-                <a:cs typeface="Jua"/>
-                <a:sym typeface="Jua"/>
+                <a:latin typeface="무궁화 고딕"/>
+                <a:ea typeface="무궁화 고딕"/>
+                <a:cs typeface="무궁화 고딕"/>
+                <a:sym typeface="무궁화 고딕"/>
               </a:rPr>
               <a:t>릴레이 공 옮기기</a:t>
             </a:r>
@@ -4008,8 +4004,8 @@
         </p:nvSpPr>
         <p:spPr>
           <a:xfrm rot="0">
-            <a:off x="15264803" y="9812655"/>
-            <a:ext cx="2637975" cy="474345"/>
+            <a:off x="14863751" y="9822180"/>
+            <a:ext cx="3039028" cy="464820"/>
           </a:xfrm>
           <a:prstGeom prst="rect">
             <a:avLst/>
@@ -4034,10 +4030,10 @@
                 <a:solidFill>
                   <a:srgbClr val="FFFFFF"/>
                 </a:solidFill>
-                <a:latin typeface="TDTD갬성명조"/>
-                <a:ea typeface="TDTD갬성명조"/>
-                <a:cs typeface="TDTD갬성명조"/>
-                <a:sym typeface="TDTD갬성명조"/>
+                <a:latin typeface="무궁화 고딕"/>
+                <a:ea typeface="무궁화 고딕"/>
+                <a:cs typeface="무궁화 고딕"/>
+                <a:sym typeface="무궁화 고딕"/>
               </a:rPr>
               <a:t>ⓒ 2026. Sunday Play</a:t>
             </a:r>
@@ -4109,8 +4105,8 @@
         </p:nvSpPr>
         <p:spPr>
           <a:xfrm rot="0">
-            <a:off x="4421807" y="3895725"/>
-            <a:ext cx="9444385" cy="2200275"/>
+            <a:off x="4421807" y="4181475"/>
+            <a:ext cx="9444385" cy="1914525"/>
           </a:xfrm>
           <a:prstGeom prst="rect">
             <a:avLst/>
@@ -4132,10 +4128,10 @@
                 <a:solidFill>
                   <a:srgbClr val="000000"/>
                 </a:solidFill>
-                <a:latin typeface="Jua"/>
-                <a:ea typeface="Jua"/>
-                <a:cs typeface="Jua"/>
-                <a:sym typeface="Jua"/>
+                <a:latin typeface="무궁화 고딕"/>
+                <a:ea typeface="무궁화 고딕"/>
+                <a:cs typeface="무궁화 고딕"/>
+                <a:sym typeface="무궁화 고딕"/>
               </a:rPr>
               <a:t>감사합니다!</a:t>
             </a:r>

</xml_diff>